<commit_message>
Update pitch deck with new screenshots and remove the ask slide
Regenerates pitch deck slides 03 and 05 with actual product screenshots, removes the ask slide (slide 12), and updates associated PPTX and PDF files, resulting in a 12-slide main deck and a 15-slide with-IP deck.

Replit-Commit-Author: Agent
Replit-Commit-Session-Id: ce089693-6854-4324-93b2-95f77a9759f4
Replit-Commit-Checkpoint-Type: full_checkpoint
Replit-Commit-Event-Id: 07c8e60d-ae2a-4a52-beaf-bdb616e87fb7
Replit-Commit-Screenshot-Url: https://storage.googleapis.com/screenshot-production-us-central1/ceb23eaa-0ec0-4109-a10a-5e37190a0ad7/ce089693-6854-4324-93b2-95f77a9759f4/a5OVRQu
Replit-Helium-Checkpoint-Created: true
</commit_message>
<xml_diff>
--- a/attached_assets/pitch-deck-slides/dime-time-pitch-deck-with-ip.pptx
+++ b/attached_assets/pitch-deck-slides/dime-time-pitch-deck-with-ip.pptx
@@ -20,7 +20,6 @@
     <p:sldId id="268" r:id="rId19"/>
     <p:sldId id="269" r:id="rId20"/>
     <p:sldId id="270" r:id="rId21"/>
-    <p:sldId id="271" r:id="rId22"/>
   </p:sldIdLst>
   <p:sldSz cx="12191695" cy="6858000" type="screen4x3"/>
   <p:notesSz cx="6858000" cy="9144000"/>
@@ -3231,7 +3230,7 @@
       <p:grpSpPr/>
       <p:pic>
         <p:nvPicPr>
-          <p:cNvPr id="2" name="Picture 1" descr="slide-12-ask.png"/>
+          <p:cNvPr id="2" name="Picture 1" descr="slide-13-appendix.png"/>
           <p:cNvPicPr>
             <a:picLocks noChangeAspect="1"/>
           </p:cNvPicPr>
@@ -3273,7 +3272,7 @@
       <p:grpSpPr/>
       <p:pic>
         <p:nvPicPr>
-          <p:cNvPr id="2" name="Picture 1" descr="slide-13-appendix.png"/>
+          <p:cNvPr id="2" name="Picture 1" descr="slide-14-patent.png"/>
           <p:cNvPicPr>
             <a:picLocks noChangeAspect="1"/>
           </p:cNvPicPr>
@@ -3315,7 +3314,7 @@
       <p:grpSpPr/>
       <p:pic>
         <p:nvPicPr>
-          <p:cNvPr id="2" name="Picture 1" descr="slide-14-patent.png"/>
+          <p:cNvPr id="2" name="Picture 1" descr="slide-15-architecture.png"/>
           <p:cNvPicPr>
             <a:picLocks noChangeAspect="1"/>
           </p:cNvPicPr>
@@ -3346,48 +3345,6 @@
 </file>
 
 <file path=ppt/slides/slide15.xml><?xml version="1.0" encoding="utf-8"?>
-<p:sld xmlns:a="http://schemas.openxmlformats.org/drawingml/2006/main" xmlns:p="http://schemas.openxmlformats.org/presentationml/2006/main" xmlns:r="http://schemas.openxmlformats.org/officeDocument/2006/relationships">
-  <p:cSld>
-    <p:spTree>
-      <p:nvGrpSpPr>
-        <p:cNvPr id="1" name=""/>
-        <p:cNvGrpSpPr/>
-        <p:nvPr/>
-      </p:nvGrpSpPr>
-      <p:grpSpPr/>
-      <p:pic>
-        <p:nvPicPr>
-          <p:cNvPr id="2" name="Picture 1" descr="slide-15-architecture.png"/>
-          <p:cNvPicPr>
-            <a:picLocks noChangeAspect="1"/>
-          </p:cNvPicPr>
-          <p:nvPr/>
-        </p:nvPicPr>
-        <p:blipFill>
-          <a:blip r:embed="rId2"/>
-          <a:stretch>
-            <a:fillRect/>
-          </a:stretch>
-        </p:blipFill>
-        <p:spPr>
-          <a:xfrm>
-            <a:off x="0" y="0"/>
-            <a:ext cx="12191695" cy="6858000"/>
-          </a:xfrm>
-          <a:prstGeom prst="rect">
-            <a:avLst/>
-          </a:prstGeom>
-        </p:spPr>
-      </p:pic>
-    </p:spTree>
-  </p:cSld>
-  <p:clrMapOvr>
-    <a:masterClrMapping/>
-  </p:clrMapOvr>
-</p:sld>
-</file>
-
-<file path=ppt/slides/slide16.xml><?xml version="1.0" encoding="utf-8"?>
 <p:sld xmlns:a="http://schemas.openxmlformats.org/drawingml/2006/main" xmlns:p="http://schemas.openxmlformats.org/presentationml/2006/main" xmlns:r="http://schemas.openxmlformats.org/officeDocument/2006/relationships">
   <p:cSld>
     <p:spTree>

</xml_diff>

<commit_message>
Update pitch deck with corrected status and details
Update pitch deck by correcting the status label for debt repayment from "LIVE IN APP" to "PROVEN IN CONTROLLED LIVE TEST", clarifying team member education and payment infrastructure descriptions, removing Coinbase from the active tech stack, and improving overall text readability and slide numbering.

Replit-Commit-Author: Agent
Replit-Commit-Session-Id: ce089693-6854-4324-93b2-95f77a9759f4
Replit-Commit-Checkpoint-Type: full_checkpoint
Replit-Commit-Event-Id: 018f17ad-117b-4b52-befb-1707d8f63ce6
Replit-Commit-Screenshot-Url: https://storage.googleapis.com/screenshot-production-us-central1/ceb23eaa-0ec0-4109-a10a-5e37190a0ad7/ce089693-6854-4324-93b2-95f77a9759f4/liOnHbu
Replit-Helium-Checkpoint-Created: true
</commit_message>
<xml_diff>
--- a/attached_assets/pitch-deck-slides/dime-time-pitch-deck-with-ip.pptx
+++ b/attached_assets/pitch-deck-slides/dime-time-pitch-deck-with-ip.pptx
@@ -3368,6 +3368,44 @@
           </a:p>
         </p:txBody>
       </p:sp>
+      <p:sp>
+        <p:nvSpPr>
+          <p:cNvPr id="9" name="TextBox 8"/>
+          <p:cNvSpPr txBox="1"/>
+          <p:nvPr/>
+        </p:nvSpPr>
+        <p:spPr>
+          <a:xfrm>
+            <a:off x="10607040" y="6355080"/>
+            <a:ext cx="1188720" cy="320040"/>
+          </a:xfrm>
+          <a:prstGeom prst="rect">
+            <a:avLst/>
+          </a:prstGeom>
+          <a:noFill/>
+        </p:spPr>
+        <p:txBody>
+          <a:bodyPr wrap="square">
+            <a:spAutoFit/>
+          </a:bodyPr>
+          <a:lstStyle/>
+          <a:p>
+            <a:pPr algn="r">
+              <a:spcAft>
+                <a:spcPts val="0"/>
+              </a:spcAft>
+            </a:pPr>
+            <a:r>
+              <a:rPr sz="1100" b="0">
+                <a:solidFill>
+                  <a:srgbClr val="E9E8FD"/>
+                </a:solidFill>
+              </a:rPr>
+              <a:t>01 / 14</a:t>
+            </a:r>
+          </a:p>
+        </p:txBody>
+      </p:sp>
     </p:spTree>
   </p:cSld>
   <p:clrMapOvr>
@@ -4021,7 +4059,7 @@
         </p:nvSpPr>
         <p:spPr>
           <a:xfrm>
-            <a:off x="1097280" y="6126480"/>
+            <a:off x="1097280" y="6108192"/>
             <a:ext cx="9966960" cy="320040"/>
           </a:xfrm>
           <a:prstGeom prst="rect">
@@ -4041,9 +4079,9 @@
               </a:spcAft>
             </a:pPr>
             <a:r>
-              <a:rPr sz="1050" b="0">
-                <a:solidFill>
-                  <a:srgbClr val="9B98C4"/>
+              <a:rPr sz="1150" b="0">
+                <a:solidFill>
+                  <a:srgbClr val="C9C7F9"/>
                 </a:solidFill>
               </a:rPr>
               <a:t>No paid-spend assumptions — channels are validated before scaling. All growth figures will be reported, not projected.</a:t>
@@ -5272,7 +5310,7 @@
         </p:nvSpPr>
         <p:spPr>
           <a:xfrm>
-            <a:off x="1828800" y="6080760"/>
+            <a:off x="1828800" y="6062472"/>
             <a:ext cx="8503920" cy="320040"/>
           </a:xfrm>
           <a:prstGeom prst="rect">
@@ -5292,9 +5330,9 @@
               </a:spcAft>
             </a:pPr>
             <a:r>
-              <a:rPr sz="1000" b="0">
-                <a:solidFill>
-                  <a:srgbClr val="9B98C4"/>
+              <a:rPr sz="1150" b="0">
+                <a:solidFill>
+                  <a:srgbClr val="C9C7F9"/>
                 </a:solidFill>
               </a:rPr>
               <a:t>No user metrics are reported until public launch — nothing on this slide is estimated.</a:t>
@@ -5828,7 +5866,7 @@
                   <a:srgbClr val="FFFFFF"/>
                 </a:solidFill>
               </a:rPr>
-              <a:t>•  MBA — Management Information Systems</a:t>
+              <a:t>•  MBA • Graduate degree in Management Information Systems</a:t>
             </a:r>
           </a:p>
           <a:p>
@@ -5858,7 +5896,7 @@
                   <a:srgbClr val="FFFFFF"/>
                 </a:solidFill>
               </a:rPr>
-              <a:t>•  Integrated Plaid, Stripe ACH and Mercury (Coinbase planned)</a:t>
+              <a:t>•  Built with Plaid and Stripe ACH; payout rails verified through Mercury</a:t>
             </a:r>
           </a:p>
         </p:txBody>
@@ -6609,27 +6647,27 @@
         </p:nvSpPr>
         <p:spPr>
           <a:xfrm>
-            <a:off x="5029200" y="2468879"/>
-            <a:ext cx="2743200" cy="365760"/>
-          </a:xfrm>
-          <a:prstGeom prst="rect">
-            <a:avLst/>
-          </a:prstGeom>
-          <a:noFill/>
-        </p:spPr>
-        <p:txBody>
-          <a:bodyPr wrap="square">
-            <a:spAutoFit/>
-          </a:bodyPr>
-          <a:lstStyle/>
-          <a:p>
-            <a:pPr algn="l">
-              <a:spcAft>
-                <a:spcPts val="0"/>
-              </a:spcAft>
-            </a:pPr>
-            <a:r>
-              <a:rPr sz="1100" b="0">
+            <a:off x="5029200" y="2496312"/>
+            <a:ext cx="3063240" cy="365760"/>
+          </a:xfrm>
+          <a:prstGeom prst="rect">
+            <a:avLst/>
+          </a:prstGeom>
+          <a:noFill/>
+        </p:spPr>
+        <p:txBody>
+          <a:bodyPr wrap="square">
+            <a:spAutoFit/>
+          </a:bodyPr>
+          <a:lstStyle/>
+          <a:p>
+            <a:pPr algn="l">
+              <a:spcAft>
+                <a:spcPts val="0"/>
+              </a:spcAft>
+            </a:pPr>
+            <a:r>
+              <a:rPr sz="1050" b="0">
                 <a:solidFill>
                   <a:srgbClr val="FFFFFF"/>
                 </a:solidFill>
@@ -6777,32 +6815,32 @@
         </p:nvSpPr>
         <p:spPr>
           <a:xfrm>
-            <a:off x="5029200" y="3364991"/>
-            <a:ext cx="2743200" cy="365760"/>
-          </a:xfrm>
-          <a:prstGeom prst="rect">
-            <a:avLst/>
-          </a:prstGeom>
-          <a:noFill/>
-        </p:spPr>
-        <p:txBody>
-          <a:bodyPr wrap="square">
-            <a:spAutoFit/>
-          </a:bodyPr>
-          <a:lstStyle/>
-          <a:p>
-            <a:pPr algn="l">
-              <a:spcAft>
-                <a:spcPts val="0"/>
-              </a:spcAft>
-            </a:pPr>
-            <a:r>
-              <a:rPr sz="1100" b="0">
-                <a:solidFill>
-                  <a:srgbClr val="FFFFFF"/>
-                </a:solidFill>
-              </a:rPr>
-              <a:t>Founder runway</a:t>
+            <a:off x="5029200" y="3392424"/>
+            <a:ext cx="3063240" cy="365760"/>
+          </a:xfrm>
+          <a:prstGeom prst="rect">
+            <a:avLst/>
+          </a:prstGeom>
+          <a:noFill/>
+        </p:spPr>
+        <p:txBody>
+          <a:bodyPr wrap="square">
+            <a:spAutoFit/>
+          </a:bodyPr>
+          <a:lstStyle/>
+          <a:p>
+            <a:pPr algn="l">
+              <a:spcAft>
+                <a:spcPts val="0"/>
+              </a:spcAft>
+            </a:pPr>
+            <a:r>
+              <a:rPr sz="1050" b="0">
+                <a:solidFill>
+                  <a:srgbClr val="FFFFFF"/>
+                </a:solidFill>
+              </a:rPr>
+              <a:t>Founder compensation &amp; operating runway</a:t>
             </a:r>
           </a:p>
         </p:txBody>
@@ -6945,27 +6983,27 @@
         </p:nvSpPr>
         <p:spPr>
           <a:xfrm>
-            <a:off x="5029200" y="4261103"/>
-            <a:ext cx="2743200" cy="365760"/>
-          </a:xfrm>
-          <a:prstGeom prst="rect">
-            <a:avLst/>
-          </a:prstGeom>
-          <a:noFill/>
-        </p:spPr>
-        <p:txBody>
-          <a:bodyPr wrap="square">
-            <a:spAutoFit/>
-          </a:bodyPr>
-          <a:lstStyle/>
-          <a:p>
-            <a:pPr algn="l">
-              <a:spcAft>
-                <a:spcPts val="0"/>
-              </a:spcAft>
-            </a:pPr>
-            <a:r>
-              <a:rPr sz="1100" b="0">
+            <a:off x="5029200" y="4288536"/>
+            <a:ext cx="3063240" cy="365760"/>
+          </a:xfrm>
+          <a:prstGeom prst="rect">
+            <a:avLst/>
+          </a:prstGeom>
+          <a:noFill/>
+        </p:spPr>
+        <p:txBody>
+          <a:bodyPr wrap="square">
+            <a:spAutoFit/>
+          </a:bodyPr>
+          <a:lstStyle/>
+          <a:p>
+            <a:pPr algn="l">
+              <a:spcAft>
+                <a:spcPts val="0"/>
+              </a:spcAft>
+            </a:pPr>
+            <a:r>
+              <a:rPr sz="1050" b="0">
                 <a:solidFill>
                   <a:srgbClr val="FFFFFF"/>
                 </a:solidFill>
@@ -7113,27 +7151,27 @@
         </p:nvSpPr>
         <p:spPr>
           <a:xfrm>
-            <a:off x="5029200" y="5157216"/>
-            <a:ext cx="2743200" cy="365760"/>
-          </a:xfrm>
-          <a:prstGeom prst="rect">
-            <a:avLst/>
-          </a:prstGeom>
-          <a:noFill/>
-        </p:spPr>
-        <p:txBody>
-          <a:bodyPr wrap="square">
-            <a:spAutoFit/>
-          </a:bodyPr>
-          <a:lstStyle/>
-          <a:p>
-            <a:pPr algn="l">
-              <a:spcAft>
-                <a:spcPts val="0"/>
-              </a:spcAft>
-            </a:pPr>
-            <a:r>
-              <a:rPr sz="1100" b="0">
+            <a:off x="5029200" y="5184648"/>
+            <a:ext cx="3063240" cy="365760"/>
+          </a:xfrm>
+          <a:prstGeom prst="rect">
+            <a:avLst/>
+          </a:prstGeom>
+          <a:noFill/>
+        </p:spPr>
+        <p:txBody>
+          <a:bodyPr wrap="square">
+            <a:spAutoFit/>
+          </a:bodyPr>
+          <a:lstStyle/>
+          <a:p>
+            <a:pPr algn="l">
+              <a:spcAft>
+                <a:spcPts val="0"/>
+              </a:spcAft>
+            </a:pPr>
+            <a:r>
+              <a:rPr sz="1050" b="0">
                 <a:solidFill>
                   <a:srgbClr val="FFFFFF"/>
                 </a:solidFill>
@@ -8942,7 +8980,7 @@
         </p:nvSpPr>
         <p:spPr>
           <a:xfrm>
-            <a:off x="658368" y="5943600"/>
+            <a:off x="658368" y="5897880"/>
             <a:ext cx="10881360" cy="320040"/>
           </a:xfrm>
           <a:prstGeom prst="rect">
@@ -8962,9 +9000,9 @@
               </a:spcAft>
             </a:pPr>
             <a:r>
-              <a:rPr sz="900" b="0">
-                <a:solidFill>
-                  <a:srgbClr val="9B98C4"/>
+              <a:rPr sz="1050" b="0">
+                <a:solidFill>
+                  <a:srgbClr val="C9C7F9"/>
                 </a:solidFill>
               </a:rPr>
               <a:t>Sources: Federal Reserve Bank of New York, Household Debt &amp; Credit Report Q1 2026 (released May 2026) · Pew Research Center, Mobile Fact Sheet (2025)</a:t>
@@ -9341,9 +9379,9 @@
               </a:spcAft>
             </a:pPr>
             <a:r>
-              <a:rPr sz="1200" b="0">
-                <a:solidFill>
-                  <a:srgbClr val="E9E8FD"/>
+              <a:rPr sz="1300" b="0">
+                <a:solidFill>
+                  <a:srgbClr val="FFFFFF"/>
                 </a:solidFill>
               </a:rPr>
               <a:t>Round-ups are batched and transferred on a schedule the user approves — money does not move on every individual purchase.</a:t>
@@ -9939,7 +9977,7 @@
         <p:spPr>
           <a:xfrm>
             <a:off x="6675120" y="2990088"/>
-            <a:ext cx="1554480" cy="310896"/>
+            <a:ext cx="4206240" cy="310896"/>
           </a:xfrm>
           <a:prstGeom prst="roundRect">
             <a:avLst>
@@ -9979,7 +10017,7 @@
                   <a:srgbClr val="FFFFFF"/>
                 </a:solidFill>
               </a:rPr>
-              <a:t>L I V E     I N     A P P</a:t>
+              <a:t>P R O V E N     I N     C O N T R O L L E D     L I V E     T E S T</a:t>
             </a:r>
           </a:p>
         </p:txBody>
@@ -11304,29 +11342,29 @@
         </p:nvSpPr>
         <p:spPr>
           <a:xfrm>
-            <a:off x="960120" y="5029200"/>
-            <a:ext cx="3703320" cy="457200"/>
-          </a:xfrm>
-          <a:prstGeom prst="rect">
-            <a:avLst/>
-          </a:prstGeom>
-          <a:noFill/>
-        </p:spPr>
-        <p:txBody>
-          <a:bodyPr wrap="square">
-            <a:spAutoFit/>
-          </a:bodyPr>
-          <a:lstStyle/>
-          <a:p>
-            <a:pPr algn="l">
-              <a:spcAft>
-                <a:spcPts val="0"/>
-              </a:spcAft>
-            </a:pPr>
-            <a:r>
-              <a:rPr sz="1050" b="0">
-                <a:solidFill>
-                  <a:srgbClr val="E9E8FD"/>
+            <a:off x="960120" y="4983480"/>
+            <a:ext cx="3703320" cy="502920"/>
+          </a:xfrm>
+          <a:prstGeom prst="rect">
+            <a:avLst/>
+          </a:prstGeom>
+          <a:noFill/>
+        </p:spPr>
+        <p:txBody>
+          <a:bodyPr wrap="square">
+            <a:spAutoFit/>
+          </a:bodyPr>
+          <a:lstStyle/>
+          <a:p>
+            <a:pPr algn="l">
+              <a:spcAft>
+                <a:spcPts val="0"/>
+              </a:spcAft>
+            </a:pPr>
+            <a:r>
+              <a:rPr sz="1150" b="0">
+                <a:solidFill>
+                  <a:srgbClr val="FFFFFF"/>
                 </a:solidFill>
               </a:rPr>
               <a:t>Context for the size of the problem — not our revenue model.</a:t>
@@ -11874,47 +11912,47 @@
               </a:spcAft>
             </a:pPr>
             <a:r>
+              <a:rPr sz="1100" b="0">
+                <a:solidFill>
+                  <a:srgbClr val="FFFFFF"/>
+                </a:solidFill>
+              </a:rPr>
+              <a:t>Subscriber counts are illustrative milestones — targets, not forecasts. ARR = subscribers × $2.99 × 12.</a:t>
+            </a:r>
+          </a:p>
+        </p:txBody>
+      </p:sp>
+      <p:sp>
+        <p:nvSpPr>
+          <p:cNvPr id="23" name="TextBox 22"/>
+          <p:cNvSpPr txBox="1"/>
+          <p:nvPr/>
+        </p:nvSpPr>
+        <p:spPr>
+          <a:xfrm>
+            <a:off x="658368" y="5897880"/>
+            <a:ext cx="10881360" cy="320040"/>
+          </a:xfrm>
+          <a:prstGeom prst="rect">
+            <a:avLst/>
+          </a:prstGeom>
+          <a:noFill/>
+        </p:spPr>
+        <p:txBody>
+          <a:bodyPr wrap="square">
+            <a:spAutoFit/>
+          </a:bodyPr>
+          <a:lstStyle/>
+          <a:p>
+            <a:pPr algn="l">
+              <a:spcAft>
+                <a:spcPts val="0"/>
+              </a:spcAft>
+            </a:pPr>
+            <a:r>
               <a:rPr sz="1050" b="0">
                 <a:solidFill>
-                  <a:srgbClr val="E9E8FD"/>
-                </a:solidFill>
-              </a:rPr>
-              <a:t>Subscriber counts are illustrative milestones — targets, not forecasts. ARR = subscribers × $2.99 × 12.</a:t>
-            </a:r>
-          </a:p>
-        </p:txBody>
-      </p:sp>
-      <p:sp>
-        <p:nvSpPr>
-          <p:cNvPr id="23" name="TextBox 22"/>
-          <p:cNvSpPr txBox="1"/>
-          <p:nvPr/>
-        </p:nvSpPr>
-        <p:spPr>
-          <a:xfrm>
-            <a:off x="658368" y="5943600"/>
-            <a:ext cx="10881360" cy="320040"/>
-          </a:xfrm>
-          <a:prstGeom prst="rect">
-            <a:avLst/>
-          </a:prstGeom>
-          <a:noFill/>
-        </p:spPr>
-        <p:txBody>
-          <a:bodyPr wrap="square">
-            <a:spAutoFit/>
-          </a:bodyPr>
-          <a:lstStyle/>
-          <a:p>
-            <a:pPr algn="l">
-              <a:spcAft>
-                <a:spcPts val="0"/>
-              </a:spcAft>
-            </a:pPr>
-            <a:r>
-              <a:rPr sz="900" b="0">
-                <a:solidFill>
-                  <a:srgbClr val="E9E8FD"/>
+                  <a:srgbClr val="FFFFFF"/>
                 </a:solidFill>
               </a:rPr>
               <a:t>Source: Federal Reserve Bank of New York, Household Debt &amp; Credit Report Q1 2026 (released May 2026)</a:t>
@@ -15238,7 +15276,7 @@
         <p:spPr>
           <a:xfrm>
             <a:off x="6858000" y="2057400"/>
-            <a:ext cx="4709160" cy="3886200"/>
+            <a:ext cx="4709160" cy="3429000"/>
           </a:xfrm>
           <a:prstGeom prst="roundRect">
             <a:avLst/>
@@ -15319,8 +15357,8 @@
         </p:nvSpPr>
         <p:spPr>
           <a:xfrm>
-            <a:off x="7114032" y="2743200"/>
-            <a:ext cx="4206240" cy="713232"/>
+            <a:off x="7114032" y="2788920"/>
+            <a:ext cx="4206240" cy="804672"/>
           </a:xfrm>
           <a:prstGeom prst="roundRect">
             <a:avLst/>
@@ -15353,7 +15391,7 @@
           <a:p>
             <a:pPr algn="l"/>
             <a:r>
-              <a:rPr sz="1500" b="1">
+              <a:rPr sz="1600" b="1">
                 <a:solidFill>
                   <a:srgbClr val="FFFFFF"/>
                 </a:solidFill>
@@ -15364,7 +15402,7 @@
           <a:p>
             <a:pPr algn="l"/>
             <a:r>
-              <a:rPr sz="1000">
+              <a:rPr sz="1100">
                 <a:solidFill>
                   <a:srgbClr val="FFFFFF"/>
                 </a:solidFill>
@@ -15382,8 +15420,8 @@
         </p:nvSpPr>
         <p:spPr>
           <a:xfrm>
-            <a:off x="7114032" y="3538728"/>
-            <a:ext cx="4206240" cy="713232"/>
+            <a:off x="7114032" y="3703320"/>
+            <a:ext cx="4206240" cy="804672"/>
           </a:xfrm>
           <a:prstGeom prst="roundRect">
             <a:avLst/>
@@ -15416,7 +15454,7 @@
           <a:p>
             <a:pPr algn="l"/>
             <a:r>
-              <a:rPr sz="1500" b="1">
+              <a:rPr sz="1600" b="1">
                 <a:solidFill>
                   <a:srgbClr val="FFFFFF"/>
                 </a:solidFill>
@@ -15427,7 +15465,7 @@
           <a:p>
             <a:pPr algn="l"/>
             <a:r>
-              <a:rPr sz="1000">
+              <a:rPr sz="1100">
                 <a:solidFill>
                   <a:srgbClr val="FFFFFF"/>
                 </a:solidFill>
@@ -15445,8 +15483,8 @@
         </p:nvSpPr>
         <p:spPr>
           <a:xfrm>
-            <a:off x="7114032" y="4334256"/>
-            <a:ext cx="4206240" cy="713232"/>
+            <a:off x="7114032" y="4617720"/>
+            <a:ext cx="4206240" cy="804672"/>
           </a:xfrm>
           <a:prstGeom prst="roundRect">
             <a:avLst/>
@@ -15479,7 +15517,7 @@
           <a:p>
             <a:pPr algn="l"/>
             <a:r>
-              <a:rPr sz="1500" b="1">
+              <a:rPr sz="1600" b="1">
                 <a:solidFill>
                   <a:srgbClr val="FFFFFF"/>
                 </a:solidFill>
@@ -15490,75 +15528,50 @@
           <a:p>
             <a:pPr algn="l"/>
             <a:r>
-              <a:rPr sz="1000">
-                <a:solidFill>
-                  <a:srgbClr val="FFFFFF"/>
-                </a:solidFill>
-              </a:rPr>
-              <a:t>Business banking &amp; treasury</a:t>
-            </a:r>
-          </a:p>
-        </p:txBody>
-      </p:sp>
-      <p:sp>
-        <p:nvSpPr>
-          <p:cNvPr id="11" name="Rounded Rectangle 10"/>
-          <p:cNvSpPr/>
-          <p:nvPr/>
-        </p:nvSpPr>
-        <p:spPr>
-          <a:xfrm>
-            <a:off x="7114032" y="5129784"/>
-            <a:ext cx="4206240" cy="713232"/>
-          </a:xfrm>
-          <a:prstGeom prst="roundRect">
-            <a:avLst/>
-          </a:prstGeom>
-          <a:solidFill>
-            <a:srgbClr val="A4A1F6"/>
-          </a:solidFill>
-          <a:ln>
-            <a:noFill/>
-          </a:ln>
-          <a:effectLst/>
-        </p:spPr>
-        <p:style>
-          <a:lnRef idx="1">
-            <a:schemeClr val="accent1"/>
-          </a:lnRef>
-          <a:fillRef idx="3">
-            <a:schemeClr val="accent1"/>
-          </a:fillRef>
-          <a:effectRef idx="2">
-            <a:schemeClr val="accent1"/>
-          </a:effectRef>
-          <a:fontRef idx="minor">
-            <a:schemeClr val="lt1"/>
-          </a:fontRef>
-        </p:style>
-        <p:txBody>
-          <a:bodyPr rtlCol="0" anchor="ctr" wrap="square" lIns="164592"/>
-          <a:lstStyle/>
-          <a:p>
-            <a:pPr algn="l"/>
-            <a:r>
-              <a:rPr sz="1500" b="1">
-                <a:solidFill>
-                  <a:srgbClr val="FFFFFF"/>
-                </a:solidFill>
-              </a:rPr>
-              <a:t>COINBASE</a:t>
-            </a:r>
-          </a:p>
-          <a:p>
-            <a:pPr algn="l"/>
-            <a:r>
-              <a:rPr sz="1000">
-                <a:solidFill>
-                  <a:srgbClr val="FFFFFF"/>
-                </a:solidFill>
-              </a:rPr>
-              <a:t>Crypto execution — planned</a:t>
+              <a:rPr sz="1100">
+                <a:solidFill>
+                  <a:srgbClr val="FFFFFF"/>
+                </a:solidFill>
+              </a:rPr>
+              <a:t>Business banking &amp; payout destination</a:t>
+            </a:r>
+          </a:p>
+        </p:txBody>
+      </p:sp>
+      <p:sp>
+        <p:nvSpPr>
+          <p:cNvPr id="11" name="TextBox 10"/>
+          <p:cNvSpPr txBox="1"/>
+          <p:nvPr/>
+        </p:nvSpPr>
+        <p:spPr>
+          <a:xfrm>
+            <a:off x="6858000" y="5596128"/>
+            <a:ext cx="4709160" cy="274320"/>
+          </a:xfrm>
+          <a:prstGeom prst="rect">
+            <a:avLst/>
+          </a:prstGeom>
+          <a:noFill/>
+        </p:spPr>
+        <p:txBody>
+          <a:bodyPr wrap="square">
+            <a:spAutoFit/>
+          </a:bodyPr>
+          <a:lstStyle/>
+          <a:p>
+            <a:pPr algn="ctr">
+              <a:spcAft>
+                <a:spcPts val="0"/>
+              </a:spcAft>
+            </a:pPr>
+            <a:r>
+              <a:rPr sz="950" b="0">
+                <a:solidFill>
+                  <a:srgbClr val="FFFFFF"/>
+                </a:solidFill>
+              </a:rPr>
+              <a:t>Partner names indicate service relationships, not endorsements.</a:t>
             </a:r>
           </a:p>
         </p:txBody>
@@ -15571,7 +15584,7 @@
         </p:nvSpPr>
         <p:spPr>
           <a:xfrm>
-            <a:off x="1097280" y="6016752"/>
+            <a:off x="1097280" y="5989320"/>
             <a:ext cx="9966960" cy="365760"/>
           </a:xfrm>
           <a:prstGeom prst="rect">
@@ -15591,9 +15604,9 @@
               </a:spcAft>
             </a:pPr>
             <a:r>
-              <a:rPr sz="1150" b="0">
-                <a:solidFill>
-                  <a:srgbClr val="E9E8FD"/>
+              <a:rPr sz="1200" b="0">
+                <a:solidFill>
+                  <a:srgbClr val="FFFFFF"/>
                 </a:solidFill>
               </a:rPr>
               <a:t>Proprietary workflow design + production financial infrastructure + partner approvals + a debt-first consumer brand.</a:t>
@@ -15603,45 +15616,7 @@
       </p:sp>
       <p:sp>
         <p:nvSpPr>
-          <p:cNvPr id="13" name="TextBox 12"/>
-          <p:cNvSpPr txBox="1"/>
-          <p:nvPr/>
-        </p:nvSpPr>
-        <p:spPr>
-          <a:xfrm>
-            <a:off x="6400800" y="6382512"/>
-            <a:ext cx="3931920" cy="274320"/>
-          </a:xfrm>
-          <a:prstGeom prst="rect">
-            <a:avLst/>
-          </a:prstGeom>
-          <a:noFill/>
-        </p:spPr>
-        <p:txBody>
-          <a:bodyPr wrap="square">
-            <a:spAutoFit/>
-          </a:bodyPr>
-          <a:lstStyle/>
-          <a:p>
-            <a:pPr algn="r">
-              <a:spcAft>
-                <a:spcPts val="0"/>
-              </a:spcAft>
-            </a:pPr>
-            <a:r>
-              <a:rPr sz="800" b="0">
-                <a:solidFill>
-                  <a:srgbClr val="E9E8FD"/>
-                </a:solidFill>
-              </a:rPr>
-              <a:t>Partner names indicate integrations, not endorsements.</a:t>
-            </a:r>
-          </a:p>
-        </p:txBody>
-      </p:sp>
-      <p:sp>
-        <p:nvSpPr>
-          <p:cNvPr id="14" name="Rectangle 13"/>
+          <p:cNvPr id="13" name="Rectangle 12"/>
           <p:cNvSpPr/>
           <p:nvPr/>
         </p:nvSpPr>
@@ -15685,7 +15660,7 @@
       </p:sp>
       <p:sp>
         <p:nvSpPr>
-          <p:cNvPr id="15" name="TextBox 14"/>
+          <p:cNvPr id="14" name="TextBox 13"/>
           <p:cNvSpPr txBox="1"/>
           <p:nvPr/>
         </p:nvSpPr>
@@ -15723,7 +15698,7 @@
       </p:sp>
       <p:sp>
         <p:nvSpPr>
-          <p:cNvPr id="16" name="TextBox 15"/>
+          <p:cNvPr id="15" name="TextBox 14"/>
           <p:cNvSpPr txBox="1"/>
           <p:nvPr/>
         </p:nvSpPr>

</xml_diff>